<commit_message>
feat: add legal pages and update branding
- Add Privacy Policy and Terms of Service pages
- Update footer with legal navigation and generic corporate identity
- Enhance Firestore security rules for user data deletion
- Refactor page routing logic for improved extensibility
</commit_message>
<xml_diff>
--- a/public/DemandAura_Presentation.pptx
+++ b/public/DemandAura_Presentation.pptx
@@ -1891,7 +1891,7 @@
                 <a:ea typeface="Arial" pitchFamily="34" charset="-122"/>
                 <a:cs typeface="Arial" pitchFamily="34" charset="-120"/>
               </a:rPr>
-              <a:t>Designed &amp; Developed by CH Srivatsava   |   github.com/sri21-3   |   linkedin.com/in/21srivatsava   |   srisrivatsava120@gmail.com</a:t>
+              <a:t>Designed &amp; Developed by DemandAura Team   |   github.com   |   linkedin.com/in/21demandaura   |   sridemandaura120@gmail.com</a:t>
             </a:r>
             <a:endParaRPr lang="en-US" sz="1000" dirty="0"/>
           </a:p>
@@ -2063,7 +2063,7 @@
                 <a:ea typeface="Arial" pitchFamily="34" charset="-122"/>
                 <a:cs typeface="Arial" pitchFamily="34" charset="-120"/>
               </a:rPr>
-              <a:t>DemandAura · CH Srivatsava</a:t>
+              <a:t>DemandAura · DemandAura Team</a:t>
             </a:r>
             <a:endParaRPr lang="en-US" sz="850" dirty="0"/>
           </a:p>
@@ -2565,7 +2565,7 @@
                 <a:ea typeface="Arial" pitchFamily="34" charset="-122"/>
                 <a:cs typeface="Arial" pitchFamily="34" charset="-120"/>
               </a:rPr>
-              <a:t>Developer: CH Srivatsava  |  github.com/sri21-3  |  linkedin.com/in/21srivatsava  |  srisrivatsava120@gmail.com</a:t>
+              <a:t>Developer: DemandAura Team  |  github.com  |  linkedin.com/in/21demandaura  |  sridemandaura120@gmail.com</a:t>
             </a:r>
             <a:endParaRPr lang="en-US" sz="1050" dirty="0"/>
           </a:p>
@@ -2737,7 +2737,7 @@
                 <a:ea typeface="Arial" pitchFamily="34" charset="-122"/>
                 <a:cs typeface="Arial" pitchFamily="34" charset="-120"/>
               </a:rPr>
-              <a:t>DemandAura · CH Srivatsava</a:t>
+              <a:t>DemandAura · DemandAura Team</a:t>
             </a:r>
             <a:endParaRPr lang="en-US" sz="850" dirty="0"/>
           </a:p>
@@ -3218,7 +3218,7 @@
                 <a:ea typeface="Arial" pitchFamily="34" charset="-122"/>
                 <a:cs typeface="Arial" pitchFamily="34" charset="-120"/>
               </a:rPr>
-              <a:t>DemandAura · CH Srivatsava</a:t>
+              <a:t>DemandAura · DemandAura Team</a:t>
             </a:r>
             <a:endParaRPr lang="en-US" sz="850" dirty="0"/>
           </a:p>
@@ -4514,7 +4514,7 @@
                 <a:ea typeface="Arial" pitchFamily="34" charset="-122"/>
                 <a:cs typeface="Arial" pitchFamily="34" charset="-120"/>
               </a:rPr>
-              <a:t>DemandAura · CH Srivatsava</a:t>
+              <a:t>DemandAura · DemandAura Team</a:t>
             </a:r>
             <a:endParaRPr lang="en-US" sz="850" dirty="0"/>
           </a:p>
@@ -5098,7 +5098,7 @@
                 <a:ea typeface="Arial" pitchFamily="34" charset="-122"/>
                 <a:cs typeface="Arial" pitchFamily="34" charset="-120"/>
               </a:rPr>
-              <a:t>DemandAura · CH Srivatsava</a:t>
+              <a:t>DemandAura · DemandAura Team</a:t>
             </a:r>
             <a:endParaRPr lang="en-US" sz="850" dirty="0"/>
           </a:p>
@@ -6132,7 +6132,7 @@
                 <a:ea typeface="Arial" pitchFamily="34" charset="-122"/>
                 <a:cs typeface="Arial" pitchFamily="34" charset="-120"/>
               </a:rPr>
-              <a:t>DemandAura · CH Srivatsava</a:t>
+              <a:t>DemandAura · DemandAura Team</a:t>
             </a:r>
             <a:endParaRPr lang="en-US" sz="850" dirty="0"/>
           </a:p>
@@ -7166,7 +7166,7 @@
                 <a:ea typeface="Arial" pitchFamily="34" charset="-122"/>
                 <a:cs typeface="Arial" pitchFamily="34" charset="-120"/>
               </a:rPr>
-              <a:t>DemandAura · CH Srivatsava</a:t>
+              <a:t>DemandAura · DemandAura Team</a:t>
             </a:r>
             <a:endParaRPr lang="en-US" sz="850" dirty="0"/>
           </a:p>
@@ -8465,7 +8465,7 @@
                 <a:ea typeface="Arial" pitchFamily="34" charset="-122"/>
                 <a:cs typeface="Arial" pitchFamily="34" charset="-120"/>
               </a:rPr>
-              <a:t>DemandAura · CH Srivatsava</a:t>
+              <a:t>DemandAura · DemandAura Team</a:t>
             </a:r>
             <a:endParaRPr lang="en-US" sz="850" dirty="0"/>
           </a:p>
@@ -8946,7 +8946,7 @@
                 <a:ea typeface="Arial" pitchFamily="34" charset="-122"/>
                 <a:cs typeface="Arial" pitchFamily="34" charset="-120"/>
               </a:rPr>
-              <a:t>DemandAura · CH Srivatsava</a:t>
+              <a:t>DemandAura · DemandAura Team</a:t>
             </a:r>
             <a:endParaRPr lang="en-US" sz="850" dirty="0"/>
           </a:p>

</xml_diff>